<commit_message>
docs(aws): SF実定義反映(ECS FARGATE/JSONata/SQS deleteMessage/posprd-cluster確認)
</commit_message>
<xml_diff>
--- a/40_AWS/01_構成資料/カスミPOS_AWS構成資料.pptx
+++ b/40_AWS/01_構成資料/カスミPOS_AWS構成資料.pptx
@@ -6076,6 +6076,45 @@
         </p:nvSpPr>
         <p:spPr>
           <a:xfrm>
+            <a:off x="5029200" y="4462272"/>
+            <a:ext cx="4572000" cy="256032"/>
+          </a:xfrm>
+          <a:prstGeom prst="rect">
+            <a:avLst/>
+          </a:prstGeom>
+          <a:noFill/>
+          <a:ln/>
+        </p:spPr>
+        <p:txBody>
+          <a:bodyPr wrap="square" lIns="0" tIns="0" rIns="0" bIns="0" rtlCol="0" anchor="ctr"/>
+          <a:lstStyle/>
+          <a:p>
+            <a:pPr indent="0" marL="0">
+              <a:buNone/>
+            </a:pPr>
+            <a:r>
+              <a:rPr lang="en-US" sz="800" dirty="0">
+                <a:solidFill>
+                  <a:srgbClr val="225577"/>
+                </a:solidFill>
+                <a:latin typeface="Calibri" pitchFamily="34" charset="0"/>
+                <a:ea typeface="Calibri" pitchFamily="34" charset="-122"/>
+                <a:cs typeface="Calibri" pitchFamily="34" charset="-120"/>
+              </a:rPr>
+              <a:t>ECS: posprd-cluster (FARGATE)  TaskDef: oc-export-data:2 / sg-export-data  QueryLanguage: JSONata  Retry: MaxAttempts:3</a:t>
+            </a:r>
+            <a:endParaRPr lang="en-US" sz="800" dirty="0"/>
+          </a:p>
+        </p:txBody>
+      </p:sp>
+      <p:sp>
+        <p:nvSpPr>
+          <p:cNvPr id="18" name="Text 11"/>
+          <p:cNvSpPr/>
+          <p:nvPr/>
+        </p:nvSpPr>
+        <p:spPr>
+          <a:xfrm>
             <a:off x="5029200" y="4206240"/>
             <a:ext cx="4572000" cy="256032"/>
           </a:xfrm>
@@ -7213,7 +7252,7 @@
                 <a:ea typeface="Calibri" pitchFamily="34" charset="-122"/>
                 <a:cs typeface="Calibri" pitchFamily="34" charset="-120"/>
               </a:rPr>
-              <a:t>{table_name}.csv + .END</a:t>
+              <a:t>{table_name}.END 着地</a:t>
             </a:r>
             <a:endParaRPr lang="en-US" sz="750" dirty="0"/>
           </a:p>
@@ -7277,7 +7316,7 @@
                 <a:ea typeface="Calibri" pitchFamily="34" charset="-122"/>
                 <a:cs typeface="Calibri" pitchFamily="34" charset="-120"/>
               </a:rPr>
-              <a:t>*.END 着地 → EventBridge</a:t>
+              <a:t>EventBridge: Object Created</a:t>
             </a:r>
             <a:endParaRPr lang="en-US" sz="750" dirty="0"/>
           </a:p>
@@ -7294,7 +7333,7 @@
                 <a:ea typeface="Calibri" pitchFamily="34" charset="-122"/>
                 <a:cs typeface="Calibri" pitchFamily="34" charset="-120"/>
               </a:rPr>
-              <a:t>→ SF: receive-pos-master-oc</a:t>
+              <a:t>*.END → SF: receive-pos-master-oc</a:t>
             </a:r>
             <a:endParaRPr lang="en-US" sz="750" dirty="0"/>
           </a:p>
@@ -7358,7 +7397,7 @@
                 <a:ea typeface="Calibri" pitchFamily="34" charset="-122"/>
                 <a:cs typeface="Calibri" pitchFamily="34" charset="-120"/>
               </a:rPr>
-              <a:t>1. Lambda: split-csv</a:t>
+              <a:t>1. SF①: split-csv</a:t>
             </a:r>
             <a:endParaRPr lang="en-US" sz="750" dirty="0"/>
           </a:p>
@@ -7375,7 +7414,24 @@
                 <a:ea typeface="Calibri" pitchFamily="34" charset="-122"/>
                 <a:cs typeface="Calibri" pitchFamily="34" charset="-120"/>
               </a:rPr>
-              <a:t>（店舗別CSV分割、.ENDIMPORT生成）</a:t>
+              <a:t>(店舗別CSV分割 + .ENDIMPORT生成)</a:t>
+            </a:r>
+            <a:endParaRPr lang="en-US" sz="750" dirty="0"/>
+          </a:p>
+          <a:p>
+            <a:pPr indent="0" marL="0">
+              <a:buNone/>
+            </a:pPr>
+            <a:r>
+              <a:rPr lang="en-US" sz="750" dirty="0">
+                <a:solidFill>
+                  <a:srgbClr val="222222"/>
+                </a:solidFill>
+                <a:latin typeface="Calibri" pitchFamily="34" charset="0"/>
+                <a:ea typeface="Calibri" pitchFamily="34" charset="-122"/>
+                <a:cs typeface="Calibri" pitchFamily="34" charset="-120"/>
+              </a:rPr>
+              <a:t>[Parallel: backup-file + Map:create-file-end]</a:t>
             </a:r>
             <a:endParaRPr lang="en-US" sz="750" dirty="0"/>
           </a:p>
@@ -7439,7 +7495,24 @@
                 <a:ea typeface="Calibri" pitchFamily="34" charset="-122"/>
                 <a:cs typeface="Calibri" pitchFamily="34" charset="-120"/>
               </a:rPr>
-              <a:t>2. Lambda: oc-import-data</a:t>
+              <a:t>2. SF②: import-pos-master-oc</a:t>
+            </a:r>
+            <a:endParaRPr lang="en-US" sz="750" dirty="0"/>
+          </a:p>
+          <a:p>
+            <a:pPr indent="0" marL="0">
+              <a:buNone/>
+            </a:pPr>
+            <a:r>
+              <a:rPr lang="en-US" sz="750" dirty="0">
+                <a:solidFill>
+                  <a:srgbClr val="222222"/>
+                </a:solidFill>
+                <a:latin typeface="Calibri" pitchFamily="34" charset="0"/>
+                <a:ea typeface="Calibri" pitchFamily="34" charset="-122"/>
+                <a:cs typeface="Calibri" pitchFamily="34" charset="-120"/>
+              </a:rPr>
+              <a:t>Lambda: oc-import-data:$LATEST</a:t>
             </a:r>
             <a:endParaRPr lang="en-US" sz="750" dirty="0"/>
           </a:p>
@@ -7520,7 +7593,7 @@
                 <a:ea typeface="Calibri" pitchFamily="34" charset="-122"/>
                 <a:cs typeface="Calibri" pitchFamily="34" charset="-120"/>
               </a:rPr>
-              <a:t>3. Lambda: backup-file</a:t>
+              <a:t>3. SF③: create-txt-file-oc</a:t>
             </a:r>
             <a:endParaRPr lang="en-US" sz="750" dirty="0"/>
           </a:p>
@@ -7537,7 +7610,41 @@
                 <a:ea typeface="Calibri" pitchFamily="34" charset="-122"/>
                 <a:cs typeface="Calibri" pitchFamily="34" charset="-120"/>
               </a:rPr>
-              <a:t>（バックアップ移動）</a:t>
+              <a:t>Lambda: get-sync-store(同期店舗確認)</a:t>
+            </a:r>
+            <a:endParaRPr lang="en-US" sz="750" dirty="0"/>
+          </a:p>
+          <a:p>
+            <a:pPr indent="0" marL="0">
+              <a:buNone/>
+            </a:pPr>
+            <a:r>
+              <a:rPr lang="en-US" sz="750" dirty="0">
+                <a:solidFill>
+                  <a:srgbClr val="222222"/>
+                </a:solidFill>
+                <a:latin typeface="Calibri" pitchFamily="34" charset="0"/>
+                <a:ea typeface="Calibri" pitchFamily="34" charset="-122"/>
+                <a:cs typeface="Calibri" pitchFamily="34" charset="-120"/>
+              </a:rPr>
+              <a:t>ECS FARGATE: oc-export-data</a:t>
+            </a:r>
+            <a:endParaRPr lang="en-US" sz="750" dirty="0"/>
+          </a:p>
+          <a:p>
+            <a:pPr indent="0" marL="0">
+              <a:buNone/>
+            </a:pPr>
+            <a:r>
+              <a:rPr lang="en-US" sz="750" dirty="0">
+                <a:solidFill>
+                  <a:srgbClr val="222222"/>
+                </a:solidFill>
+                <a:latin typeface="Calibri" pitchFamily="34" charset="0"/>
+                <a:ea typeface="Calibri" pitchFamily="34" charset="-122"/>
+                <a:cs typeface="Calibri" pitchFamily="34" charset="-120"/>
+              </a:rPr>
+              <a:t>(posprd-cluster, TaskDef:v2)</a:t>
             </a:r>
             <a:endParaRPr lang="en-US" sz="750" dirty="0"/>
           </a:p>
@@ -7601,7 +7708,7 @@
                 <a:ea typeface="Calibri" pitchFamily="34" charset="-122"/>
                 <a:cs typeface="Calibri" pitchFamily="34" charset="-120"/>
               </a:rPr>
-              <a:t>4. EventBridge → SF: create-txt-file-oc</a:t>
+              <a:t>4. Lambda: split-txt-by-sent-time</a:t>
             </a:r>
             <a:endParaRPr lang="en-US" sz="750" dirty="0"/>
           </a:p>
@@ -7618,7 +7725,7 @@
                 <a:ea typeface="Calibri" pitchFamily="34" charset="-122"/>
                 <a:cs typeface="Calibri" pitchFamily="34" charset="-120"/>
               </a:rPr>
-              <a:t>ECS: oc-export-data → SHOHIN.TXT生成</a:t>
+              <a:t>(TXT分割 + 送信スケジュール設定)</a:t>
             </a:r>
             <a:endParaRPr lang="en-US" sz="750" dirty="0"/>
           </a:p>
@@ -7682,7 +7789,7 @@
                 <a:ea typeface="Calibri" pitchFamily="34" charset="-122"/>
                 <a:cs typeface="Calibri" pitchFamily="34" charset="-120"/>
               </a:rPr>
-              <a:t>5. SF: sent-txt-file</a:t>
+              <a:t>5. SF④: sent-txt-file</a:t>
             </a:r>
             <a:endParaRPr lang="en-US" sz="750" dirty="0"/>
           </a:p>
@@ -7699,7 +7806,7 @@
                 <a:ea typeface="Calibri" pitchFamily="34" charset="-122"/>
                 <a:cs typeface="Calibri" pitchFamily="34" charset="-120"/>
               </a:rPr>
-              <a:t>Lambda: sent-txt-file → BOX-PC FTP送信</a:t>
+              <a:t>→ BOX-PC FTP送信 + backup-file</a:t>
             </a:r>
             <a:endParaRPr lang="en-US" sz="750" dirty="0"/>
           </a:p>
@@ -7844,7 +7951,7 @@
                 <a:ea typeface="Calibri" pitchFamily="34" charset="-122"/>
                 <a:cs typeface="Calibri" pitchFamily="34" charset="-120"/>
               </a:rPr>
-              <a:t>出力: SHOHIN.TXT → BOX-PC</a:t>
+              <a:t>出力: SHOHIN.TXT</a:t>
             </a:r>
             <a:endParaRPr lang="en-US" sz="750" dirty="0"/>
           </a:p>
@@ -8070,7 +8177,7 @@
                 <a:ea typeface="Calibri" pitchFamily="34" charset="-122"/>
                 <a:cs typeface="Calibri" pitchFamily="34" charset="-120"/>
               </a:rPr>
-              <a:t>{company}_{store}_yyyymmdd.ZIP</a:t>
+              <a:t>*.ZIP 着地</a:t>
             </a:r>
             <a:endParaRPr lang="en-US" sz="750" dirty="0"/>
           </a:p>
@@ -8134,7 +8241,7 @@
                 <a:ea typeface="Calibri" pitchFamily="34" charset="-122"/>
                 <a:cs typeface="Calibri" pitchFamily="34" charset="-120"/>
               </a:rPr>
-              <a:t>*.ZIP 着地 → EventBridge</a:t>
+              <a:t>EventBridge: Object Created</a:t>
             </a:r>
             <a:endParaRPr lang="en-US" sz="750" dirty="0"/>
           </a:p>
@@ -8151,7 +8258,24 @@
                 <a:ea typeface="Calibri" pitchFamily="34" charset="-122"/>
                 <a:cs typeface="Calibri" pitchFamily="34" charset="-120"/>
               </a:rPr>
-              <a:t>→ SF: receive-and-import-pos-master-sg</a:t>
+              <a:t>*.ZIP → SQS: store-code-queue.fifo</a:t>
+            </a:r>
+            <a:endParaRPr lang="en-US" sz="750" dirty="0"/>
+          </a:p>
+          <a:p>
+            <a:pPr indent="0" marL="0">
+              <a:buNone/>
+            </a:pPr>
+            <a:r>
+              <a:rPr lang="en-US" sz="750" dirty="0">
+                <a:solidFill>
+                  <a:srgbClr val="C0392B"/>
+                </a:solidFill>
+                <a:latin typeface="Calibri" pitchFamily="34" charset="0"/>
+                <a:ea typeface="Calibri" pitchFamily="34" charset="-122"/>
+                <a:cs typeface="Calibri" pitchFamily="34" charset="-120"/>
+              </a:rPr>
+              <a:t>→ SF: receive-and-import-sg</a:t>
             </a:r>
             <a:endParaRPr lang="en-US" sz="750" dirty="0"/>
           </a:p>
@@ -8215,7 +8339,7 @@
                 <a:ea typeface="Calibri" pitchFamily="34" charset="-122"/>
                 <a:cs typeface="Calibri" pitchFamily="34" charset="-120"/>
               </a:rPr>
-              <a:t>1. Lambda: unzip-file</a:t>
+              <a:t>1. SF①: receive-and-import-sg</a:t>
             </a:r>
             <a:endParaRPr lang="en-US" sz="750" dirty="0"/>
           </a:p>
@@ -8232,7 +8356,24 @@
                 <a:ea typeface="Calibri" pitchFamily="34" charset="-122"/>
                 <a:cs typeface="Calibri" pitchFamily="34" charset="-120"/>
               </a:rPr>
-              <a:t>（ZIP展開、テーブル別フォルダ移動）</a:t>
+              <a:t>Lambda: unzip-file</a:t>
+            </a:r>
+            <a:endParaRPr lang="en-US" sz="750" dirty="0"/>
+          </a:p>
+          <a:p>
+            <a:pPr indent="0" marL="0">
+              <a:buNone/>
+            </a:pPr>
+            <a:r>
+              <a:rPr lang="en-US" sz="750" dirty="0">
+                <a:solidFill>
+                  <a:srgbClr val="222222"/>
+                </a:solidFill>
+                <a:latin typeface="Calibri" pitchFamily="34" charset="0"/>
+                <a:ea typeface="Calibri" pitchFamily="34" charset="-122"/>
+                <a:cs typeface="Calibri" pitchFamily="34" charset="-120"/>
+              </a:rPr>
+              <a:t>(ZIP展開 + テーブル別移動)</a:t>
             </a:r>
             <a:endParaRPr lang="en-US" sz="750" dirty="0"/>
           </a:p>
@@ -8296,7 +8437,7 @@
                 <a:ea typeface="Calibri" pitchFamily="34" charset="-122"/>
                 <a:cs typeface="Calibri" pitchFamily="34" charset="-120"/>
               </a:rPr>
-              <a:t>2. Lambda: sg-import-data [Parallel/Map]</a:t>
+              <a:t>2. [Parallel]</a:t>
             </a:r>
             <a:endParaRPr lang="en-US" sz="750" dirty="0"/>
           </a:p>
@@ -8313,7 +8454,58 @@
                 <a:ea typeface="Calibri" pitchFamily="34" charset="-122"/>
                 <a:cs typeface="Calibri" pitchFamily="34" charset="-120"/>
               </a:rPr>
-              <a:t>→ Replica_Kasumi (11/13/16)</a:t>
+              <a:t>① backup-file (ZIPバックアップ)</a:t>
+            </a:r>
+            <a:endParaRPr lang="en-US" sz="750" dirty="0"/>
+          </a:p>
+          <a:p>
+            <a:pPr indent="0" marL="0">
+              <a:buNone/>
+            </a:pPr>
+            <a:r>
+              <a:rPr lang="en-US" sz="750" dirty="0">
+                <a:solidFill>
+                  <a:srgbClr val="222222"/>
+                </a:solidFill>
+                <a:latin typeface="Calibri" pitchFamily="34" charset="0"/>
+                <a:ea typeface="Calibri" pitchFamily="34" charset="-122"/>
+                <a:cs typeface="Calibri" pitchFamily="34" charset="-120"/>
+              </a:rPr>
+              <a:t>② Map: sg-import-data:$LATEST</a:t>
+            </a:r>
+            <a:endParaRPr lang="en-US" sz="750" dirty="0"/>
+          </a:p>
+          <a:p>
+            <a:pPr indent="0" marL="0">
+              <a:buNone/>
+            </a:pPr>
+            <a:r>
+              <a:rPr lang="en-US" sz="750" dirty="0">
+                <a:solidFill>
+                  <a:srgbClr val="222222"/>
+                </a:solidFill>
+                <a:latin typeface="Calibri" pitchFamily="34" charset="0"/>
+                <a:ea typeface="Calibri" pitchFamily="34" charset="-122"/>
+                <a:cs typeface="Calibri" pitchFamily="34" charset="-120"/>
+              </a:rPr>
+              <a:t>  → Replica_Kasumi (11/13/16)</a:t>
+            </a:r>
+            <a:endParaRPr lang="en-US" sz="750" dirty="0"/>
+          </a:p>
+          <a:p>
+            <a:pPr indent="0" marL="0">
+              <a:buNone/>
+            </a:pPr>
+            <a:r>
+              <a:rPr lang="en-US" sz="750" dirty="0">
+                <a:solidFill>
+                  <a:srgbClr val="222222"/>
+                </a:solidFill>
+                <a:latin typeface="Calibri" pitchFamily="34" charset="0"/>
+                <a:ea typeface="Calibri" pitchFamily="34" charset="-122"/>
+                <a:cs typeface="Calibri" pitchFamily="34" charset="-120"/>
+              </a:rPr>
+              <a:t>  ※エラー時SQS deleteMessage</a:t>
             </a:r>
             <a:endParaRPr lang="en-US" sz="750" dirty="0"/>
           </a:p>
@@ -8377,7 +8569,7 @@
                 <a:ea typeface="Calibri" pitchFamily="34" charset="-122"/>
                 <a:cs typeface="Calibri" pitchFamily="34" charset="-120"/>
               </a:rPr>
-              <a:t>3. Lambda: create-file-end → .ENDEXPORT</a:t>
+              <a:t>3. .ENDEXPORT生成</a:t>
             </a:r>
             <a:endParaRPr lang="en-US" sz="750" dirty="0"/>
           </a:p>
@@ -8394,7 +8586,24 @@
                 <a:ea typeface="Calibri" pitchFamily="34" charset="-122"/>
                 <a:cs typeface="Calibri" pitchFamily="34" charset="-120"/>
               </a:rPr>
-              <a:t>SQS: store-code-queue-sg.fifo</a:t>
+              <a:t>→ EventBridge: Object Created</a:t>
+            </a:r>
+            <a:endParaRPr lang="en-US" sz="750" dirty="0"/>
+          </a:p>
+          <a:p>
+            <a:pPr indent="0" marL="0">
+              <a:buNone/>
+            </a:pPr>
+            <a:r>
+              <a:rPr lang="en-US" sz="750" dirty="0">
+                <a:solidFill>
+                  <a:srgbClr val="222222"/>
+                </a:solidFill>
+                <a:latin typeface="Calibri" pitchFamily="34" charset="0"/>
+                <a:ea typeface="Calibri" pitchFamily="34" charset="-122"/>
+                <a:cs typeface="Calibri" pitchFamily="34" charset="-120"/>
+              </a:rPr>
+              <a:t>→ SF: create-txt-file-sg</a:t>
             </a:r>
             <a:endParaRPr lang="en-US" sz="750" dirty="0"/>
           </a:p>
@@ -8458,7 +8667,7 @@
                 <a:ea typeface="Calibri" pitchFamily="34" charset="-122"/>
                 <a:cs typeface="Calibri" pitchFamily="34" charset="-120"/>
               </a:rPr>
-              <a:t>4. EventBridge → SF: create-txt-file-sg</a:t>
+              <a:t>4. ECS FARGATE: sg-export-data</a:t>
             </a:r>
             <a:endParaRPr lang="en-US" sz="750" dirty="0"/>
           </a:p>
@@ -8475,7 +8684,24 @@
                 <a:ea typeface="Calibri" pitchFamily="34" charset="-122"/>
                 <a:cs typeface="Calibri" pitchFamily="34" charset="-120"/>
               </a:rPr>
-              <a:t>ECS: sg-export-data → ESLDATA.TXT生成</a:t>
+              <a:t>(posprd-cluster)</a:t>
+            </a:r>
+            <a:endParaRPr lang="en-US" sz="750" dirty="0"/>
+          </a:p>
+          <a:p>
+            <a:pPr indent="0" marL="0">
+              <a:buNone/>
+            </a:pPr>
+            <a:r>
+              <a:rPr lang="en-US" sz="750" dirty="0">
+                <a:solidFill>
+                  <a:srgbClr val="222222"/>
+                </a:solidFill>
+                <a:latin typeface="Calibri" pitchFamily="34" charset="0"/>
+                <a:ea typeface="Calibri" pitchFamily="34" charset="-122"/>
+                <a:cs typeface="Calibri" pitchFamily="34" charset="-120"/>
+              </a:rPr>
+              <a:t>Lambda: split-txt-by-sent-time</a:t>
             </a:r>
             <a:endParaRPr lang="en-US" sz="750" dirty="0"/>
           </a:p>
@@ -8539,7 +8765,7 @@
                 <a:ea typeface="Calibri" pitchFamily="34" charset="-122"/>
                 <a:cs typeface="Calibri" pitchFamily="34" charset="-120"/>
               </a:rPr>
-              <a:t>5. SF: sent-txt-file</a:t>
+              <a:t>5. SF②: sent-txt-file</a:t>
             </a:r>
             <a:endParaRPr lang="en-US" sz="750" dirty="0"/>
           </a:p>
@@ -8556,7 +8782,7 @@
                 <a:ea typeface="Calibri" pitchFamily="34" charset="-122"/>
                 <a:cs typeface="Calibri" pitchFamily="34" charset="-120"/>
               </a:rPr>
-              <a:t>Lambda: sent-txt-file → BOX-PC FTP送信</a:t>
+              <a:t>→ BOX-PC FTP送信 + backup-file</a:t>
             </a:r>
             <a:endParaRPr lang="en-US" sz="750" dirty="0"/>
           </a:p>
@@ -8654,7 +8880,7 @@
                 <a:ea typeface="Calibri" pitchFamily="34" charset="-122"/>
                 <a:cs typeface="Calibri" pitchFamily="34" charset="-120"/>
               </a:rPr>
-              <a:t>・13_SpecicalPriceKsmMaster</a:t>
+              <a:t>・13_SpecialPriceMaster</a:t>
             </a:r>
             <a:endParaRPr lang="en-US" sz="750" dirty="0"/>
           </a:p>
@@ -8735,7 +8961,7 @@
                 <a:ea typeface="Calibri" pitchFamily="34" charset="-122"/>
                 <a:cs typeface="Calibri" pitchFamily="34" charset="-120"/>
               </a:rPr>
-              <a:t>出力: ESLDATA.TXT → BOX-PC</a:t>
+              <a:t>出力: ESLDATA.TXT</a:t>
             </a:r>
             <a:endParaRPr lang="en-US" sz="750" dirty="0"/>
           </a:p>
@@ -8961,7 +9187,7 @@
                 <a:ea typeface="Calibri" pitchFamily="34" charset="-122"/>
                 <a:cs typeface="Calibri" pitchFamily="34" charset="-120"/>
               </a:rPr>
-              <a:t>{table_name}.csv + .END</a:t>
+              <a:t>{table_name}.END 着地</a:t>
             </a:r>
             <a:endParaRPr lang="en-US" sz="750" dirty="0"/>
           </a:p>
@@ -9025,7 +9251,7 @@
                 <a:ea typeface="Calibri" pitchFamily="34" charset="-122"/>
                 <a:cs typeface="Calibri" pitchFamily="34" charset="-120"/>
               </a:rPr>
-              <a:t>*.END 着地 → EventBridge</a:t>
+              <a:t>EventBridge: Object Created</a:t>
             </a:r>
             <a:endParaRPr lang="en-US" sz="750" dirty="0"/>
           </a:p>
@@ -9042,7 +9268,7 @@
                 <a:ea typeface="Calibri" pitchFamily="34" charset="-122"/>
                 <a:cs typeface="Calibri" pitchFamily="34" charset="-120"/>
               </a:rPr>
-              <a:t>→ SF: import-pos-master-sh</a:t>
+              <a:t>*.END → SF: import-pos-master-sh</a:t>
             </a:r>
             <a:endParaRPr lang="en-US" sz="750" dirty="0"/>
           </a:p>
@@ -9106,7 +9332,7 @@
                 <a:ea typeface="Calibri" pitchFamily="34" charset="-122"/>
                 <a:cs typeface="Calibri" pitchFamily="34" charset="-120"/>
               </a:rPr>
-              <a:t>1. Lambda: import-pos-master-sh</a:t>
+              <a:t>1. SF①: import-pos-master-sh</a:t>
             </a:r>
             <a:endParaRPr lang="en-US" sz="750" dirty="0"/>
           </a:p>
@@ -9123,7 +9349,24 @@
                 <a:ea typeface="Calibri" pitchFamily="34" charset="-122"/>
                 <a:cs typeface="Calibri" pitchFamily="34" charset="-120"/>
               </a:rPr>
-              <a:t>（DB接続・ファイルダウンロード）</a:t>
+              <a:t>Lambda: import-pos-master-sh</a:t>
+            </a:r>
+            <a:endParaRPr lang="en-US" sz="750" dirty="0"/>
+          </a:p>
+          <a:p>
+            <a:pPr indent="0" marL="0">
+              <a:buNone/>
+            </a:pPr>
+            <a:r>
+              <a:rPr lang="en-US" sz="750" dirty="0">
+                <a:solidFill>
+                  <a:srgbClr val="222222"/>
+                </a:solidFill>
+                <a:latin typeface="Calibri" pitchFamily="34" charset="0"/>
+                <a:ea typeface="Calibri" pitchFamily="34" charset="-122"/>
+                <a:cs typeface="Calibri" pitchFamily="34" charset="-120"/>
+              </a:rPr>
+              <a:t>(DB接続・S3ダウンロード)</a:t>
             </a:r>
             <a:endParaRPr lang="en-US" sz="750" dirty="0"/>
           </a:p>
@@ -9204,6 +9447,23 @@
                 <a:ea typeface="Calibri" pitchFamily="34" charset="-122"/>
                 <a:cs typeface="Calibri" pitchFamily="34" charset="-120"/>
               </a:rPr>
+              <a:t>(INSERT/UPDATE)</a:t>
+            </a:r>
+            <a:endParaRPr lang="en-US" sz="750" dirty="0"/>
+          </a:p>
+          <a:p>
+            <a:pPr indent="0" marL="0">
+              <a:buNone/>
+            </a:pPr>
+            <a:r>
+              <a:rPr lang="en-US" sz="750" dirty="0">
+                <a:solidFill>
+                  <a:srgbClr val="222222"/>
+                </a:solidFill>
+                <a:latin typeface="Calibri" pitchFamily="34" charset="0"/>
+                <a:ea typeface="Calibri" pitchFamily="34" charset="-122"/>
+                <a:cs typeface="Calibri" pitchFamily="34" charset="-120"/>
+              </a:rPr>
               <a:t>バッチステータス更新</a:t>
             </a:r>
             <a:endParaRPr lang="en-US" sz="750" dirty="0"/>
@@ -9285,7 +9545,7 @@
                 <a:ea typeface="Calibri" pitchFamily="34" charset="-122"/>
                 <a:cs typeface="Calibri" pitchFamily="34" charset="-120"/>
               </a:rPr>
-              <a:t>（バックアップ移動）</a:t>
+              <a:t>(バックアップ移動)</a:t>
             </a:r>
             <a:endParaRPr lang="en-US" sz="750" dirty="0"/>
           </a:p>
@@ -9349,7 +9609,24 @@
                 <a:ea typeface="Calibri" pitchFamily="34" charset="-122"/>
                 <a:cs typeface="Calibri" pitchFamily="34" charset="-120"/>
               </a:rPr>
-              <a:t>4. （SHはTXTエクスポートなし）</a:t>
+              <a:t>4. （SHはTXT出力・</a:t>
+            </a:r>
+            <a:endParaRPr lang="en-US" sz="750" dirty="0"/>
+          </a:p>
+          <a:p>
+            <a:pPr indent="0" marL="0">
+              <a:buNone/>
+            </a:pPr>
+            <a:r>
+              <a:rPr lang="en-US" sz="750" dirty="0">
+                <a:solidFill>
+                  <a:srgbClr val="222222"/>
+                </a:solidFill>
+                <a:latin typeface="Calibri" pitchFamily="34" charset="0"/>
+                <a:ea typeface="Calibri" pitchFamily="34" charset="-122"/>
+                <a:cs typeface="Calibri" pitchFamily="34" charset="-120"/>
+              </a:rPr>
+              <a:t>BOX-PC送信なし）</a:t>
             </a:r>
             <a:endParaRPr lang="en-US" sz="750" dirty="0"/>
           </a:p>

</xml_diff>